<commit_message>
Update project files: security fixes, presentation updates, and credential template
</commit_message>
<xml_diff>
--- a/Refund_Intelligence_Platform_BoB-a-Thon_V1.0.pptx
+++ b/Refund_Intelligence_Platform_BoB-a-Thon_V1.0.pptx
@@ -5,7 +5,7 @@
     <p:sldMasterId id="2147483648" r:id="rId1"/>
   </p:sldMasterIdLst>
   <p:notesMasterIdLst>
-    <p:notesMasterId r:id="rId17"/>
+    <p:notesMasterId r:id="rId18"/>
   </p:notesMasterIdLst>
   <p:sldIdLst>
     <p:sldId id="256" r:id="rId2"/>
@@ -18,11 +18,12 @@
     <p:sldId id="266" r:id="rId9"/>
     <p:sldId id="264" r:id="rId10"/>
     <p:sldId id="261" r:id="rId11"/>
-    <p:sldId id="269" r:id="rId12"/>
-    <p:sldId id="268" r:id="rId13"/>
-    <p:sldId id="265" r:id="rId14"/>
-    <p:sldId id="260" r:id="rId15"/>
-    <p:sldId id="270" r:id="rId16"/>
+    <p:sldId id="271" r:id="rId12"/>
+    <p:sldId id="269" r:id="rId13"/>
+    <p:sldId id="268" r:id="rId14"/>
+    <p:sldId id="265" r:id="rId15"/>
+    <p:sldId id="260" r:id="rId16"/>
+    <p:sldId id="270" r:id="rId17"/>
   </p:sldIdLst>
   <p:sldSz cx="9144000" cy="5143500" type="screen16x9"/>
   <p:notesSz cx="5143500" cy="9144000"/>
@@ -451,6 +452,114 @@
         <p:cNvPr id="1" name="">
           <a:extLst>
             <a:ext uri="{FF2B5EF4-FFF2-40B4-BE49-F238E27FC236}">
+              <a16:creationId xmlns:a16="http://schemas.microsoft.com/office/drawing/2014/main" id="{70360F3F-85F2-E934-B7B8-BE723268DE86}"/>
+            </a:ext>
+          </a:extLst>
+        </p:cNvPr>
+        <p:cNvGrpSpPr/>
+        <p:nvPr/>
+      </p:nvGrpSpPr>
+      <p:grpSpPr>
+        <a:xfrm>
+          <a:off x="0" y="0"/>
+          <a:ext cx="0" cy="0"/>
+          <a:chOff x="0" y="0"/>
+          <a:chExt cx="0" cy="0"/>
+        </a:xfrm>
+      </p:grpSpPr>
+      <p:sp>
+        <p:nvSpPr>
+          <p:cNvPr id="2" name="Slide Image Placeholder 1">
+            <a:extLst>
+              <a:ext uri="{FF2B5EF4-FFF2-40B4-BE49-F238E27FC236}">
+                <a16:creationId xmlns:a16="http://schemas.microsoft.com/office/drawing/2014/main" id="{67DBCF63-687B-1B07-344B-450811A7CEE0}"/>
+              </a:ext>
+            </a:extLst>
+          </p:cNvPr>
+          <p:cNvSpPr>
+            <a:spLocks noGrp="1" noRot="1" noChangeAspect="1"/>
+          </p:cNvSpPr>
+          <p:nvPr>
+            <p:ph type="sldImg"/>
+          </p:nvPr>
+        </p:nvSpPr>
+        <p:spPr/>
+      </p:sp>
+      <p:sp>
+        <p:nvSpPr>
+          <p:cNvPr id="3" name="Notes Placeholder 2">
+            <a:extLst>
+              <a:ext uri="{FF2B5EF4-FFF2-40B4-BE49-F238E27FC236}">
+                <a16:creationId xmlns:a16="http://schemas.microsoft.com/office/drawing/2014/main" id="{936494E1-0E8A-BA4C-09BD-3BB4544BFECC}"/>
+              </a:ext>
+            </a:extLst>
+          </p:cNvPr>
+          <p:cNvSpPr>
+            <a:spLocks noGrp="1"/>
+          </p:cNvSpPr>
+          <p:nvPr>
+            <p:ph type="body" idx="1"/>
+          </p:nvPr>
+        </p:nvSpPr>
+        <p:spPr/>
+        <p:txBody>
+          <a:bodyPr/>
+          <a:lstStyle/>
+          <a:p>
+            <a:endParaRPr lang="en-US" dirty="0"/>
+          </a:p>
+        </p:txBody>
+      </p:sp>
+      <p:sp>
+        <p:nvSpPr>
+          <p:cNvPr id="4" name="Slide Number Placeholder 3">
+            <a:extLst>
+              <a:ext uri="{FF2B5EF4-FFF2-40B4-BE49-F238E27FC236}">
+                <a16:creationId xmlns:a16="http://schemas.microsoft.com/office/drawing/2014/main" id="{2EFEFC2E-228A-24B1-65D5-55EEE8198C46}"/>
+              </a:ext>
+            </a:extLst>
+          </p:cNvPr>
+          <p:cNvSpPr>
+            <a:spLocks noGrp="1"/>
+          </p:cNvSpPr>
+          <p:nvPr>
+            <p:ph type="sldNum" sz="quarter" idx="10"/>
+          </p:nvPr>
+        </p:nvSpPr>
+        <p:spPr/>
+        <p:txBody>
+          <a:bodyPr/>
+          <a:lstStyle/>
+          <a:p>
+            <a:fld id="{F7021451-1387-4CA6-816F-3879F97B5CBC}" type="slidenum">
+              <a:rPr lang="en-US"/>
+              <a:t>11</a:t>
+            </a:fld>
+            <a:endParaRPr lang="en-US"/>
+          </a:p>
+        </p:txBody>
+      </p:sp>
+    </p:spTree>
+    <p:extLst>
+      <p:ext uri="{BB962C8B-B14F-4D97-AF65-F5344CB8AC3E}">
+        <p14:creationId xmlns:p14="http://schemas.microsoft.com/office/powerpoint/2010/main" val="1611656355"/>
+      </p:ext>
+    </p:extLst>
+  </p:cSld>
+  <p:clrMapOvr>
+    <a:masterClrMapping/>
+  </p:clrMapOvr>
+</p:notes>
+</file>
+
+<file path=ppt/notesSlides/notesSlide12.xml><?xml version="1.0" encoding="utf-8"?>
+<p:notes xmlns:a="http://schemas.openxmlformats.org/drawingml/2006/main" xmlns:r="http://schemas.openxmlformats.org/officeDocument/2006/relationships" xmlns:p="http://schemas.openxmlformats.org/presentationml/2006/main">
+  <p:cSld>
+    <p:spTree>
+      <p:nvGrpSpPr>
+        <p:cNvPr id="1" name="">
+          <a:extLst>
+            <a:ext uri="{FF2B5EF4-FFF2-40B4-BE49-F238E27FC236}">
               <a16:creationId xmlns:a16="http://schemas.microsoft.com/office/drawing/2014/main" id="{BA2ED1F9-01E9-6219-3547-4623ECD0FF12}"/>
             </a:ext>
           </a:extLst>
@@ -532,7 +641,7 @@
           <a:p>
             <a:fld id="{F7021451-1387-4CA6-816F-3879F97B5CBC}" type="slidenum">
               <a:rPr lang="en-US"/>
-              <a:t>11</a:t>
+              <a:t>12</a:t>
             </a:fld>
             <a:endParaRPr lang="en-US"/>
           </a:p>
@@ -551,7 +660,7 @@
 </p:notes>
 </file>
 
-<file path=ppt/notesSlides/notesSlide12.xml><?xml version="1.0" encoding="utf-8"?>
+<file path=ppt/notesSlides/notesSlide13.xml><?xml version="1.0" encoding="utf-8"?>
 <p:notes xmlns:a="http://schemas.openxmlformats.org/drawingml/2006/main" xmlns:r="http://schemas.openxmlformats.org/officeDocument/2006/relationships" xmlns:p="http://schemas.openxmlformats.org/presentationml/2006/main">
   <p:cSld>
     <p:spTree>
@@ -640,7 +749,7 @@
           <a:p>
             <a:fld id="{F7021451-1387-4CA6-816F-3879F97B5CBC}" type="slidenum">
               <a:rPr lang="en-US"/>
-              <a:t>12</a:t>
+              <a:t>13</a:t>
             </a:fld>
             <a:endParaRPr lang="en-US"/>
           </a:p>
@@ -659,7 +768,7 @@
 </p:notes>
 </file>
 
-<file path=ppt/notesSlides/notesSlide13.xml><?xml version="1.0" encoding="utf-8"?>
+<file path=ppt/notesSlides/notesSlide14.xml><?xml version="1.0" encoding="utf-8"?>
 <p:notes xmlns:a="http://schemas.openxmlformats.org/drawingml/2006/main" xmlns:r="http://schemas.openxmlformats.org/officeDocument/2006/relationships" xmlns:p="http://schemas.openxmlformats.org/presentationml/2006/main">
   <p:cSld>
     <p:spTree>
@@ -748,7 +857,7 @@
           <a:p>
             <a:fld id="{F7021451-1387-4CA6-816F-3879F97B5CBC}" type="slidenum">
               <a:rPr lang="en-US"/>
-              <a:t>13</a:t>
+              <a:t>14</a:t>
             </a:fld>
             <a:endParaRPr lang="en-US"/>
           </a:p>
@@ -767,7 +876,7 @@
 </p:notes>
 </file>
 
-<file path=ppt/notesSlides/notesSlide14.xml><?xml version="1.0" encoding="utf-8"?>
+<file path=ppt/notesSlides/notesSlide15.xml><?xml version="1.0" encoding="utf-8"?>
 <p:notes xmlns:a="http://schemas.openxmlformats.org/drawingml/2006/main" xmlns:r="http://schemas.openxmlformats.org/officeDocument/2006/relationships" xmlns:p="http://schemas.openxmlformats.org/presentationml/2006/main">
   <p:cSld>
     <p:spTree>
@@ -832,7 +941,7 @@
           <a:p>
             <a:fld id="{F7021451-1387-4CA6-816F-3879F97B5CBC}" type="slidenum">
               <a:rPr lang="en-US"/>
-              <a:t>14</a:t>
+              <a:t>15</a:t>
             </a:fld>
             <a:endParaRPr lang="en-US"/>
           </a:p>
@@ -851,7 +960,7 @@
 </p:notes>
 </file>
 
-<file path=ppt/notesSlides/notesSlide15.xml><?xml version="1.0" encoding="utf-8"?>
+<file path=ppt/notesSlides/notesSlide16.xml><?xml version="1.0" encoding="utf-8"?>
 <p:notes xmlns:a="http://schemas.openxmlformats.org/drawingml/2006/main" xmlns:r="http://schemas.openxmlformats.org/officeDocument/2006/relationships" xmlns:p="http://schemas.openxmlformats.org/presentationml/2006/main">
   <p:cSld>
     <p:spTree>
@@ -940,7 +1049,7 @@
           <a:p>
             <a:fld id="{F7021451-1387-4CA6-816F-3879F97B5CBC}" type="slidenum">
               <a:rPr lang="en-US"/>
-              <a:t>15</a:t>
+              <a:t>16</a:t>
             </a:fld>
             <a:endParaRPr lang="en-US"/>
           </a:p>
@@ -2578,6 +2687,166 @@
         <p:cNvPr id="1" name="">
           <a:extLst>
             <a:ext uri="{FF2B5EF4-FFF2-40B4-BE49-F238E27FC236}">
+              <a16:creationId xmlns:a16="http://schemas.microsoft.com/office/drawing/2014/main" id="{81F05F7B-EFA5-A6E6-2D9D-C906C64BCEA8}"/>
+            </a:ext>
+          </a:extLst>
+        </p:cNvPr>
+        <p:cNvGrpSpPr/>
+        <p:nvPr/>
+      </p:nvGrpSpPr>
+      <p:grpSpPr>
+        <a:xfrm>
+          <a:off x="0" y="0"/>
+          <a:ext cx="0" cy="0"/>
+          <a:chOff x="0" y="0"/>
+          <a:chExt cx="0" cy="0"/>
+        </a:xfrm>
+      </p:grpSpPr>
+      <p:sp>
+        <p:nvSpPr>
+          <p:cNvPr id="2" name="Shape 0">
+            <a:extLst>
+              <a:ext uri="{FF2B5EF4-FFF2-40B4-BE49-F238E27FC236}">
+                <a16:creationId xmlns:a16="http://schemas.microsoft.com/office/drawing/2014/main" id="{31B6B190-D8B3-8F5F-C33B-86C07C8977F2}"/>
+              </a:ext>
+            </a:extLst>
+          </p:cNvPr>
+          <p:cNvSpPr/>
+          <p:nvPr/>
+        </p:nvSpPr>
+        <p:spPr>
+          <a:xfrm>
+            <a:off x="0" y="0"/>
+            <a:ext cx="164592" cy="5143500"/>
+          </a:xfrm>
+          <a:prstGeom prst="rect">
+            <a:avLst/>
+          </a:prstGeom>
+          <a:solidFill>
+            <a:srgbClr val="4BA3C3"/>
+          </a:solidFill>
+          <a:ln/>
+        </p:spPr>
+        <p:txBody>
+          <a:bodyPr/>
+          <a:lstStyle/>
+          <a:p>
+            <a:endParaRPr lang="en-IN"/>
+          </a:p>
+        </p:txBody>
+      </p:sp>
+      <p:sp>
+        <p:nvSpPr>
+          <p:cNvPr id="3" name="Text 1">
+            <a:extLst>
+              <a:ext uri="{FF2B5EF4-FFF2-40B4-BE49-F238E27FC236}">
+                <a16:creationId xmlns:a16="http://schemas.microsoft.com/office/drawing/2014/main" id="{33BE79B6-59AE-398A-D7A3-C33340094EE0}"/>
+              </a:ext>
+            </a:extLst>
+          </p:cNvPr>
+          <p:cNvSpPr/>
+          <p:nvPr/>
+        </p:nvSpPr>
+        <p:spPr>
+          <a:xfrm>
+            <a:off x="3877339" y="149903"/>
+            <a:ext cx="1389321" cy="414696"/>
+          </a:xfrm>
+          <a:prstGeom prst="rect">
+            <a:avLst/>
+          </a:prstGeom>
+          <a:noFill/>
+          <a:ln/>
+        </p:spPr>
+        <p:txBody>
+          <a:bodyPr wrap="square" lIns="0" tIns="0" rIns="0" bIns="0" rtlCol="0" anchor="ctr"/>
+          <a:lstStyle/>
+          <a:p>
+            <a:pPr marL="0" indent="0">
+              <a:buNone/>
+            </a:pPr>
+            <a:r>
+              <a:rPr lang="en-US" sz="2000" b="1" dirty="0">
+                <a:solidFill>
+                  <a:srgbClr val="7C5CBF"/>
+                </a:solidFill>
+                <a:latin typeface="Calibri" pitchFamily="34" charset="0"/>
+                <a:ea typeface="Calibri" pitchFamily="34" charset="-122"/>
+                <a:cs typeface="Calibri" pitchFamily="34" charset="-120"/>
+              </a:rPr>
+              <a:t>Agent Test</a:t>
+            </a:r>
+            <a:endParaRPr lang="en-US" sz="2000" dirty="0"/>
+          </a:p>
+        </p:txBody>
+      </p:sp>
+      <p:pic>
+        <p:nvPicPr>
+          <p:cNvPr id="5" name="Picture 4">
+            <a:extLst>
+              <a:ext uri="{FF2B5EF4-FFF2-40B4-BE49-F238E27FC236}">
+                <a16:creationId xmlns:a16="http://schemas.microsoft.com/office/drawing/2014/main" id="{B623F3E7-A9E7-654A-B427-00E01E0A7786}"/>
+              </a:ext>
+            </a:extLst>
+          </p:cNvPr>
+          <p:cNvPicPr>
+            <a:picLocks noChangeAspect="1"/>
+          </p:cNvPicPr>
+          <p:nvPr/>
+        </p:nvPicPr>
+        <p:blipFill>
+          <a:blip r:embed="rId3"/>
+          <a:stretch>
+            <a:fillRect/>
+          </a:stretch>
+        </p:blipFill>
+        <p:spPr>
+          <a:xfrm>
+            <a:off x="1104686" y="545284"/>
+            <a:ext cx="6681782" cy="4375222"/>
+          </a:xfrm>
+          <a:prstGeom prst="rect">
+            <a:avLst/>
+          </a:prstGeom>
+          <a:solidFill>
+            <a:schemeClr val="tx1"/>
+          </a:solidFill>
+          <a:ln>
+            <a:solidFill>
+              <a:schemeClr val="tx1"/>
+            </a:solidFill>
+          </a:ln>
+        </p:spPr>
+      </p:pic>
+    </p:spTree>
+    <p:extLst>
+      <p:ext uri="{BB962C8B-B14F-4D97-AF65-F5344CB8AC3E}">
+        <p14:creationId xmlns:p14="http://schemas.microsoft.com/office/powerpoint/2010/main" val="113028966"/>
+      </p:ext>
+    </p:extLst>
+  </p:cSld>
+  <p:clrMapOvr>
+    <a:masterClrMapping/>
+  </p:clrMapOvr>
+</p:sld>
+</file>
+
+<file path=ppt/slides/slide12.xml><?xml version="1.0" encoding="utf-8"?>
+<p:sld xmlns:a="http://schemas.openxmlformats.org/drawingml/2006/main" xmlns:r="http://schemas.openxmlformats.org/officeDocument/2006/relationships" xmlns:p="http://schemas.openxmlformats.org/presentationml/2006/main">
+  <p:cSld>
+    <p:bg>
+      <p:bgPr>
+        <a:solidFill>
+          <a:srgbClr val="F7F4FF"/>
+        </a:solidFill>
+        <a:effectLst/>
+      </p:bgPr>
+    </p:bg>
+    <p:spTree>
+      <p:nvGrpSpPr>
+        <p:cNvPr id="1" name="">
+          <a:extLst>
+            <a:ext uri="{FF2B5EF4-FFF2-40B4-BE49-F238E27FC236}">
               <a16:creationId xmlns:a16="http://schemas.microsoft.com/office/drawing/2014/main" id="{9D2C8E12-9BC3-3F72-6215-5C52887B82F1}"/>
             </a:ext>
           </a:extLst>
@@ -3049,7 +3318,7 @@
 </p:sld>
 </file>
 
-<file path=ppt/slides/slide12.xml><?xml version="1.0" encoding="utf-8"?>
+<file path=ppt/slides/slide13.xml><?xml version="1.0" encoding="utf-8"?>
 <p:sld xmlns:a="http://schemas.openxmlformats.org/drawingml/2006/main" xmlns:r="http://schemas.openxmlformats.org/officeDocument/2006/relationships" xmlns:p="http://schemas.openxmlformats.org/presentationml/2006/main">
   <p:cSld>
     <p:bg>
@@ -3248,7 +3517,7 @@
 </p:sld>
 </file>
 
-<file path=ppt/slides/slide13.xml><?xml version="1.0" encoding="utf-8"?>
+<file path=ppt/slides/slide14.xml><?xml version="1.0" encoding="utf-8"?>
 <p:sld xmlns:a="http://schemas.openxmlformats.org/drawingml/2006/main" xmlns:r="http://schemas.openxmlformats.org/officeDocument/2006/relationships" xmlns:p="http://schemas.openxmlformats.org/presentationml/2006/main">
   <p:cSld>
     <p:bg>
@@ -3687,7 +3956,7 @@
 </p:sld>
 </file>
 
-<file path=ppt/slides/slide14.xml><?xml version="1.0" encoding="utf-8"?>
+<file path=ppt/slides/slide15.xml><?xml version="1.0" encoding="utf-8"?>
 <p:sld xmlns:a="http://schemas.openxmlformats.org/drawingml/2006/main" xmlns:r="http://schemas.openxmlformats.org/officeDocument/2006/relationships" xmlns:p="http://schemas.openxmlformats.org/presentationml/2006/main">
   <p:cSld name="Slide 5">
     <p:bg>
@@ -4514,7 +4783,7 @@
 </p:sld>
 </file>
 
-<file path=ppt/slides/slide15.xml><?xml version="1.0" encoding="utf-8"?>
+<file path=ppt/slides/slide16.xml><?xml version="1.0" encoding="utf-8"?>
 <p:sld xmlns:a="http://schemas.openxmlformats.org/drawingml/2006/main" xmlns:r="http://schemas.openxmlformats.org/officeDocument/2006/relationships" xmlns:p="http://schemas.openxmlformats.org/presentationml/2006/main">
   <p:cSld>
     <p:bg>
@@ -4844,6 +5113,15 @@
               </a:rPr>
               <a:t>This project represents the future of AI-powered business applications that are intelligent, explainable, and seamlessly integrated.</a:t>
             </a:r>
+          </a:p>
+          <a:p>
+            <a:pPr marL="0" indent="0">
+              <a:buNone/>
+              <a:defRPr sz="1600" b="0"/>
+            </a:pPr>
+            <a:endParaRPr lang="en-US" sz="1200" dirty="0">
+              <a:latin typeface="IBM Plex Sans" panose="020B0503050203000203" pitchFamily="34" charset="0"/>
+            </a:endParaRPr>
           </a:p>
         </p:txBody>
       </p:sp>

</xml_diff>